<commit_message>
Update forecasting to predict next month, even when the latest data is outdated
</commit_message>
<xml_diff>
--- a/Cambodia_Food_Price_Forecast.pptx
+++ b/Cambodia_Food_Price_Forecast.pptx
@@ -3347,7 +3347,7 @@
                 </a:solidFill>
                 <a:latin typeface="Segoe UI"/>
               </a:rPr>
-              <a:t>Forecasting food commodity prices in Cambodia — from World Food Programme price monitoring to a live web app and a Telegram bot.</a:t>
+              <a:t>Forecasting food commodity prices in Cambodia — from World Food Programme price monitoring to a web app and a Telegram bot.</a:t>
             </a:r>
           </a:p>
         </p:txBody>
@@ -7204,7 +7204,7 @@
                 </a:solidFill>
                 <a:latin typeface="Consolas"/>
               </a:rPr>
-              <a:t>HONESTY</a:t>
+              <a:t>FORECAST HORIZON</a:t>
             </a:r>
           </a:p>
         </p:txBody>
@@ -7246,7 +7246,7 @@
                 </a:solidFill>
                 <a:latin typeface="Georgia"/>
               </a:rPr>
-              <a:t>The chart ends</a:t>
+              <a:t>One period past the record,</a:t>
             </a:r>
           </a:p>
         </p:txBody>
@@ -7288,7 +7288,7 @@
                 </a:solidFill>
                 <a:latin typeface="Georgia"/>
               </a:rPr>
-              <a:t>in June 2022</a:t>
+              <a:t>not one month past today</a:t>
             </a:r>
           </a:p>
         </p:txBody>
@@ -7344,7 +7344,7 @@
         <p:spPr>
           <a:xfrm>
             <a:off x="822960" y="2240280"/>
-            <a:ext cx="5760720" cy="1463040"/>
+            <a:ext cx="5120640" cy="1463040"/>
           </a:xfrm>
           <a:prstGeom prst="rect">
             <a:avLst/>
@@ -7366,13 +7366,13 @@
               </a:spcAft>
             </a:pPr>
             <a:r>
-              <a:rPr sz="1650" b="0" i="0">
+              <a:rPr sz="1600" b="0" i="0">
                 <a:solidFill>
                   <a:srgbClr val="191E19"/>
                 </a:solidFill>
                 <a:latin typeface="Segoe UI"/>
               </a:rPr>
-              <a:t>The dataset runs to March 2026. This series does not. Rice wholesale prices in Phnom Penh stopped being reported in June 2022, and the app says so instead of carrying the line forward to look current.</a:t>
+              <a:t>The model forecasts one reporting period past each series' own last observation — not one month past today. Series stopped reporting at very different times, so that date differs for every commodity and market.</a:t>
             </a:r>
           </a:p>
         </p:txBody>
@@ -7385,64 +7385,678 @@
         </p:nvSpPr>
         <p:spPr>
           <a:xfrm>
-            <a:off x="822960" y="3840480"/>
-            <a:ext cx="5760720" cy="1371600"/>
-          </a:xfrm>
-          <a:prstGeom prst="rect">
-            <a:avLst/>
-          </a:prstGeom>
-          <a:noFill/>
-        </p:spPr>
-        <p:txBody>
-          <a:bodyPr wrap="square" anchor="t" lIns="0" rIns="0" tIns="0" bIns="0">
-            <a:spAutoFit/>
-          </a:bodyPr>
-          <a:lstStyle/>
-          <a:p>
-            <a:pPr algn="l">
-              <a:lnSpc>
-                <a:spcPct val="150000"/>
-              </a:lnSpc>
-              <a:spcAft>
-                <a:spcPts val="0"/>
-              </a:spcAft>
-            </a:pPr>
-            <a:r>
-              <a:rPr sz="1450" b="0" i="0">
+            <a:off x="822960" y="3794760"/>
+            <a:ext cx="5120640" cy="274320"/>
+          </a:xfrm>
+          <a:prstGeom prst="rect">
+            <a:avLst/>
+          </a:prstGeom>
+          <a:noFill/>
+        </p:spPr>
+        <p:txBody>
+          <a:bodyPr wrap="square" anchor="t" lIns="0" rIns="0" tIns="0" bIns="0">
+            <a:spAutoFit/>
+          </a:bodyPr>
+          <a:lstStyle/>
+          <a:p>
+            <a:pPr algn="l">
+              <a:lnSpc>
+                <a:spcPct val="130000"/>
+              </a:lnSpc>
+              <a:spcAft>
+                <a:spcPts val="0"/>
+              </a:spcAft>
+            </a:pPr>
+            <a:r>
+              <a:rPr sz="1000" b="0" i="0" spc="160">
                 <a:solidFill>
                   <a:srgbClr val="5C625A"/>
                 </a:solidFill>
+                <a:latin typeface="Consolas"/>
+              </a:rPr>
+              <a:t>LAST OBSERVATION ACROSS 3,442 SERVED SERIES</a:t>
+            </a:r>
+          </a:p>
+        </p:txBody>
+      </p:sp>
+      <p:sp>
+        <p:nvSpPr>
+          <p:cNvPr id="9" name="Rectangle 8"/>
+          <p:cNvSpPr/>
+          <p:nvPr/>
+        </p:nvSpPr>
+        <p:spPr>
+          <a:xfrm>
+            <a:off x="822960" y="4160520"/>
+            <a:ext cx="957782" cy="201168"/>
+          </a:xfrm>
+          <a:prstGeom prst="rect">
+            <a:avLst/>
+          </a:prstGeom>
+          <a:solidFill>
+            <a:srgbClr val="2F5D46"/>
+          </a:solidFill>
+          <a:ln>
+            <a:noFill/>
+          </a:ln>
+          <a:effectLst/>
+        </p:spPr>
+        <p:style>
+          <a:lnRef idx="1">
+            <a:schemeClr val="accent1"/>
+          </a:lnRef>
+          <a:fillRef idx="3">
+            <a:schemeClr val="accent1"/>
+          </a:fillRef>
+          <a:effectRef idx="2">
+            <a:schemeClr val="accent1"/>
+          </a:effectRef>
+          <a:fontRef idx="minor">
+            <a:schemeClr val="lt1"/>
+          </a:fontRef>
+        </p:style>
+        <p:txBody>
+          <a:bodyPr rtlCol="0" anchor="ctr"/>
+          <a:lstStyle/>
+          <a:p>
+            <a:pPr algn="ctr"/>
+          </a:p>
+        </p:txBody>
+      </p:sp>
+      <p:sp>
+        <p:nvSpPr>
+          <p:cNvPr id="10" name="TextBox 9"/>
+          <p:cNvSpPr txBox="1"/>
+          <p:nvPr/>
+        </p:nvSpPr>
+        <p:spPr>
+          <a:xfrm>
+            <a:off x="1872182" y="4133088"/>
+            <a:ext cx="640080" cy="274320"/>
+          </a:xfrm>
+          <a:prstGeom prst="rect">
+            <a:avLst/>
+          </a:prstGeom>
+          <a:noFill/>
+        </p:spPr>
+        <p:txBody>
+          <a:bodyPr wrap="square" anchor="t" lIns="0" rIns="0" tIns="0" bIns="0">
+            <a:spAutoFit/>
+          </a:bodyPr>
+          <a:lstStyle/>
+          <a:p>
+            <a:pPr algn="l">
+              <a:lnSpc>
+                <a:spcPct val="130000"/>
+              </a:lnSpc>
+              <a:spcAft>
+                <a:spcPts val="0"/>
+              </a:spcAft>
+            </a:pPr>
+            <a:r>
+              <a:rPr sz="1150" b="1" i="0">
+                <a:solidFill>
+                  <a:srgbClr val="2F5D46"/>
+                </a:solidFill>
+                <a:latin typeface="Consolas"/>
+              </a:rPr>
+              <a:t>34%</a:t>
+            </a:r>
+          </a:p>
+        </p:txBody>
+      </p:sp>
+      <p:sp>
+        <p:nvSpPr>
+          <p:cNvPr id="11" name="TextBox 10"/>
+          <p:cNvSpPr txBox="1"/>
+          <p:nvPr/>
+        </p:nvSpPr>
+        <p:spPr>
+          <a:xfrm>
+            <a:off x="822960" y="4398264"/>
+            <a:ext cx="4937760" cy="274320"/>
+          </a:xfrm>
+          <a:prstGeom prst="rect">
+            <a:avLst/>
+          </a:prstGeom>
+          <a:noFill/>
+        </p:spPr>
+        <p:txBody>
+          <a:bodyPr wrap="square" anchor="t" lIns="0" rIns="0" tIns="0" bIns="0">
+            <a:spAutoFit/>
+          </a:bodyPr>
+          <a:lstStyle/>
+          <a:p>
+            <a:pPr algn="l">
+              <a:lnSpc>
+                <a:spcPct val="130000"/>
+              </a:lnSpc>
+              <a:spcAft>
+                <a:spcPts val="0"/>
+              </a:spcAft>
+            </a:pPr>
+            <a:r>
+              <a:rPr sz="1250" b="0" i="0">
+                <a:solidFill>
+                  <a:srgbClr val="5C625A"/>
+                </a:solidFill>
                 <a:latin typeface="Segoe UI"/>
               </a:rPr>
-              <a:t>Interpolating to today would have made every screenshot look better and every number less true. Of 4,035 series in the data, many stopped reporting years apart — a single “latest” date across the app would be fiction.</a:t>
-            </a:r>
-          </a:p>
-        </p:txBody>
-      </p:sp>
-      <p:pic>
-        <p:nvPicPr>
-          <p:cNvPr id="9" name="Picture 8" descr="board_card.png"/>
-          <p:cNvPicPr>
-            <a:picLocks noChangeAspect="1"/>
-          </p:cNvPicPr>
-          <p:nvPr/>
-        </p:nvPicPr>
-        <p:blipFill>
-          <a:blip r:embed="rId2"/>
-          <a:stretch>
-            <a:fillRect/>
-          </a:stretch>
-        </p:blipFill>
-        <p:spPr>
-          <a:xfrm>
-            <a:off x="6675120" y="2514600"/>
-            <a:ext cx="4937760" cy="1789938"/>
-          </a:xfrm>
-          <a:prstGeom prst="rect">
-            <a:avLst/>
-          </a:prstGeom>
-        </p:spPr>
-      </p:pic>
+              <a:t>2026-03 — still reporting  ·  1,163</a:t>
+            </a:r>
+          </a:p>
+        </p:txBody>
+      </p:sp>
+      <p:sp>
+        <p:nvSpPr>
+          <p:cNvPr id="12" name="Rectangle 11"/>
+          <p:cNvSpPr/>
+          <p:nvPr/>
+        </p:nvSpPr>
+        <p:spPr>
+          <a:xfrm>
+            <a:off x="822960" y="4818888"/>
+            <a:ext cx="286593" cy="201168"/>
+          </a:xfrm>
+          <a:prstGeom prst="rect">
+            <a:avLst/>
+          </a:prstGeom>
+          <a:solidFill>
+            <a:srgbClr val="A06D05"/>
+          </a:solidFill>
+          <a:ln>
+            <a:noFill/>
+          </a:ln>
+          <a:effectLst/>
+        </p:spPr>
+        <p:style>
+          <a:lnRef idx="1">
+            <a:schemeClr val="accent1"/>
+          </a:lnRef>
+          <a:fillRef idx="3">
+            <a:schemeClr val="accent1"/>
+          </a:fillRef>
+          <a:effectRef idx="2">
+            <a:schemeClr val="accent1"/>
+          </a:effectRef>
+          <a:fontRef idx="minor">
+            <a:schemeClr val="lt1"/>
+          </a:fontRef>
+        </p:style>
+        <p:txBody>
+          <a:bodyPr rtlCol="0" anchor="ctr"/>
+          <a:lstStyle/>
+          <a:p>
+            <a:pPr algn="ctr"/>
+          </a:p>
+        </p:txBody>
+      </p:sp>
+      <p:sp>
+        <p:nvSpPr>
+          <p:cNvPr id="13" name="TextBox 12"/>
+          <p:cNvSpPr txBox="1"/>
+          <p:nvPr/>
+        </p:nvSpPr>
+        <p:spPr>
+          <a:xfrm>
+            <a:off x="1200993" y="4791456"/>
+            <a:ext cx="640080" cy="274320"/>
+          </a:xfrm>
+          <a:prstGeom prst="rect">
+            <a:avLst/>
+          </a:prstGeom>
+          <a:noFill/>
+        </p:spPr>
+        <p:txBody>
+          <a:bodyPr wrap="square" anchor="t" lIns="0" rIns="0" tIns="0" bIns="0">
+            <a:spAutoFit/>
+          </a:bodyPr>
+          <a:lstStyle/>
+          <a:p>
+            <a:pPr algn="l">
+              <a:lnSpc>
+                <a:spcPct val="130000"/>
+              </a:lnSpc>
+              <a:spcAft>
+                <a:spcPts val="0"/>
+              </a:spcAft>
+            </a:pPr>
+            <a:r>
+              <a:rPr sz="1150" b="1" i="0">
+                <a:solidFill>
+                  <a:srgbClr val="A06D05"/>
+                </a:solidFill>
+                <a:latin typeface="Consolas"/>
+              </a:rPr>
+              <a:t>10%</a:t>
+            </a:r>
+          </a:p>
+        </p:txBody>
+      </p:sp>
+      <p:sp>
+        <p:nvSpPr>
+          <p:cNvPr id="14" name="TextBox 13"/>
+          <p:cNvSpPr txBox="1"/>
+          <p:nvPr/>
+        </p:nvSpPr>
+        <p:spPr>
+          <a:xfrm>
+            <a:off x="822960" y="5056632"/>
+            <a:ext cx="4937760" cy="274320"/>
+          </a:xfrm>
+          <a:prstGeom prst="rect">
+            <a:avLst/>
+          </a:prstGeom>
+          <a:noFill/>
+        </p:spPr>
+        <p:txBody>
+          <a:bodyPr wrap="square" anchor="t" lIns="0" rIns="0" tIns="0" bIns="0">
+            <a:spAutoFit/>
+          </a:bodyPr>
+          <a:lstStyle/>
+          <a:p>
+            <a:pPr algn="l">
+              <a:lnSpc>
+                <a:spcPct val="130000"/>
+              </a:lnSpc>
+              <a:spcAft>
+                <a:spcPts val="0"/>
+              </a:spcAft>
+            </a:pPr>
+            <a:r>
+              <a:rPr sz="1250" b="0" i="0">
+                <a:solidFill>
+                  <a:srgbClr val="5C625A"/>
+                </a:solidFill>
+                <a:latin typeface="Segoe UI"/>
+              </a:rPr>
+              <a:t>2025 — recently stopped  ·  348</a:t>
+            </a:r>
+          </a:p>
+        </p:txBody>
+      </p:sp>
+      <p:sp>
+        <p:nvSpPr>
+          <p:cNvPr id="15" name="Rectangle 14"/>
+          <p:cNvSpPr/>
+          <p:nvPr/>
+        </p:nvSpPr>
+        <p:spPr>
+          <a:xfrm>
+            <a:off x="822960" y="5477256"/>
+            <a:ext cx="1590264" cy="201168"/>
+          </a:xfrm>
+          <a:prstGeom prst="rect">
+            <a:avLst/>
+          </a:prstGeom>
+          <a:solidFill>
+            <a:srgbClr val="6B2545"/>
+          </a:solidFill>
+          <a:ln>
+            <a:noFill/>
+          </a:ln>
+          <a:effectLst/>
+        </p:spPr>
+        <p:style>
+          <a:lnRef idx="1">
+            <a:schemeClr val="accent1"/>
+          </a:lnRef>
+          <a:fillRef idx="3">
+            <a:schemeClr val="accent1"/>
+          </a:fillRef>
+          <a:effectRef idx="2">
+            <a:schemeClr val="accent1"/>
+          </a:effectRef>
+          <a:fontRef idx="minor">
+            <a:schemeClr val="lt1"/>
+          </a:fontRef>
+        </p:style>
+        <p:txBody>
+          <a:bodyPr rtlCol="0" anchor="ctr"/>
+          <a:lstStyle/>
+          <a:p>
+            <a:pPr algn="ctr"/>
+          </a:p>
+        </p:txBody>
+      </p:sp>
+      <p:sp>
+        <p:nvSpPr>
+          <p:cNvPr id="16" name="TextBox 15"/>
+          <p:cNvSpPr txBox="1"/>
+          <p:nvPr/>
+        </p:nvSpPr>
+        <p:spPr>
+          <a:xfrm>
+            <a:off x="2504664" y="5449824"/>
+            <a:ext cx="640080" cy="274320"/>
+          </a:xfrm>
+          <a:prstGeom prst="rect">
+            <a:avLst/>
+          </a:prstGeom>
+          <a:noFill/>
+        </p:spPr>
+        <p:txBody>
+          <a:bodyPr wrap="square" anchor="t" lIns="0" rIns="0" tIns="0" bIns="0">
+            <a:spAutoFit/>
+          </a:bodyPr>
+          <a:lstStyle/>
+          <a:p>
+            <a:pPr algn="l">
+              <a:lnSpc>
+                <a:spcPct val="130000"/>
+              </a:lnSpc>
+              <a:spcAft>
+                <a:spcPts val="0"/>
+              </a:spcAft>
+            </a:pPr>
+            <a:r>
+              <a:rPr sz="1150" b="1" i="0">
+                <a:solidFill>
+                  <a:srgbClr val="6B2545"/>
+                </a:solidFill>
+                <a:latin typeface="Consolas"/>
+              </a:rPr>
+              <a:t>56%</a:t>
+            </a:r>
+          </a:p>
+        </p:txBody>
+      </p:sp>
+      <p:sp>
+        <p:nvSpPr>
+          <p:cNvPr id="17" name="TextBox 16"/>
+          <p:cNvSpPr txBox="1"/>
+          <p:nvPr/>
+        </p:nvSpPr>
+        <p:spPr>
+          <a:xfrm>
+            <a:off x="822960" y="5715000"/>
+            <a:ext cx="4937760" cy="274320"/>
+          </a:xfrm>
+          <a:prstGeom prst="rect">
+            <a:avLst/>
+          </a:prstGeom>
+          <a:noFill/>
+        </p:spPr>
+        <p:txBody>
+          <a:bodyPr wrap="square" anchor="t" lIns="0" rIns="0" tIns="0" bIns="0">
+            <a:spAutoFit/>
+          </a:bodyPr>
+          <a:lstStyle/>
+          <a:p>
+            <a:pPr algn="l">
+              <a:lnSpc>
+                <a:spcPct val="130000"/>
+              </a:lnSpc>
+              <a:spcAft>
+                <a:spcPts val="0"/>
+              </a:spcAft>
+            </a:pPr>
+            <a:r>
+              <a:rPr sz="1250" b="0" i="0">
+                <a:solidFill>
+                  <a:srgbClr val="5C625A"/>
+                </a:solidFill>
+                <a:latin typeface="Segoe UI"/>
+              </a:rPr>
+              <a:t>2024 or earlier — stale  ·  1,931</a:t>
+            </a:r>
+          </a:p>
+        </p:txBody>
+      </p:sp>
+      <p:sp>
+        <p:nvSpPr>
+          <p:cNvPr id="18" name="Rectangle 17"/>
+          <p:cNvSpPr/>
+          <p:nvPr/>
+        </p:nvSpPr>
+        <p:spPr>
+          <a:xfrm>
+            <a:off x="6336792" y="2194560"/>
+            <a:ext cx="5029200" cy="3611880"/>
+          </a:xfrm>
+          <a:prstGeom prst="rect">
+            <a:avLst/>
+          </a:prstGeom>
+          <a:solidFill>
+            <a:srgbClr val="FCFBF7"/>
+          </a:solidFill>
+          <a:ln w="12700">
+            <a:solidFill>
+              <a:srgbClr val="DCD9C9"/>
+            </a:solidFill>
+          </a:ln>
+          <a:effectLst/>
+        </p:spPr>
+        <p:style>
+          <a:lnRef idx="1">
+            <a:schemeClr val="accent1"/>
+          </a:lnRef>
+          <a:fillRef idx="3">
+            <a:schemeClr val="accent1"/>
+          </a:fillRef>
+          <a:effectRef idx="2">
+            <a:schemeClr val="accent1"/>
+          </a:effectRef>
+          <a:fontRef idx="minor">
+            <a:schemeClr val="lt1"/>
+          </a:fontRef>
+        </p:style>
+        <p:txBody>
+          <a:bodyPr rtlCol="0" anchor="ctr"/>
+          <a:lstStyle/>
+          <a:p>
+            <a:pPr algn="ctr"/>
+          </a:p>
+        </p:txBody>
+      </p:sp>
+      <p:sp>
+        <p:nvSpPr>
+          <p:cNvPr id="19" name="Rectangle 18"/>
+          <p:cNvSpPr/>
+          <p:nvPr/>
+        </p:nvSpPr>
+        <p:spPr>
+          <a:xfrm>
+            <a:off x="6336792" y="2194560"/>
+            <a:ext cx="45720" cy="3611880"/>
+          </a:xfrm>
+          <a:prstGeom prst="rect">
+            <a:avLst/>
+          </a:prstGeom>
+          <a:solidFill>
+            <a:srgbClr val="2F5D46"/>
+          </a:solidFill>
+          <a:ln>
+            <a:noFill/>
+          </a:ln>
+          <a:effectLst/>
+        </p:spPr>
+        <p:style>
+          <a:lnRef idx="1">
+            <a:schemeClr val="accent1"/>
+          </a:lnRef>
+          <a:fillRef idx="3">
+            <a:schemeClr val="accent1"/>
+          </a:fillRef>
+          <a:effectRef idx="2">
+            <a:schemeClr val="accent1"/>
+          </a:effectRef>
+          <a:fontRef idx="minor">
+            <a:schemeClr val="lt1"/>
+          </a:fontRef>
+        </p:style>
+        <p:txBody>
+          <a:bodyPr rtlCol="0" anchor="ctr"/>
+          <a:lstStyle/>
+          <a:p>
+            <a:pPr algn="ctr"/>
+          </a:p>
+        </p:txBody>
+      </p:sp>
+      <p:sp>
+        <p:nvSpPr>
+          <p:cNvPr id="20" name="TextBox 19"/>
+          <p:cNvSpPr txBox="1"/>
+          <p:nvPr/>
+        </p:nvSpPr>
+        <p:spPr>
+          <a:xfrm>
+            <a:off x="6702552" y="2487168"/>
+            <a:ext cx="4297680" cy="274320"/>
+          </a:xfrm>
+          <a:prstGeom prst="rect">
+            <a:avLst/>
+          </a:prstGeom>
+          <a:noFill/>
+        </p:spPr>
+        <p:txBody>
+          <a:bodyPr wrap="square" anchor="t" lIns="0" rIns="0" tIns="0" bIns="0">
+            <a:spAutoFit/>
+          </a:bodyPr>
+          <a:lstStyle/>
+          <a:p>
+            <a:pPr algn="l">
+              <a:lnSpc>
+                <a:spcPct val="130000"/>
+              </a:lnSpc>
+              <a:spcAft>
+                <a:spcPts val="0"/>
+              </a:spcAft>
+            </a:pPr>
+            <a:r>
+              <a:rPr sz="1000" b="0" i="0" spc="160">
+                <a:solidFill>
+                  <a:srgbClr val="2F5D46"/>
+                </a:solidFill>
+                <a:latin typeface="Consolas"/>
+              </a:rPr>
+              <a:t>SO IS IT ACTUALLY FORECASTING?</a:t>
+            </a:r>
+          </a:p>
+        </p:txBody>
+      </p:sp>
+      <p:sp>
+        <p:nvSpPr>
+          <p:cNvPr id="21" name="TextBox 20"/>
+          <p:cNvSpPr txBox="1"/>
+          <p:nvPr/>
+        </p:nvSpPr>
+        <p:spPr>
+          <a:xfrm>
+            <a:off x="6702552" y="2926080"/>
+            <a:ext cx="4297680" cy="2651760"/>
+          </a:xfrm>
+          <a:prstGeom prst="rect">
+            <a:avLst/>
+          </a:prstGeom>
+          <a:noFill/>
+        </p:spPr>
+        <p:txBody>
+          <a:bodyPr wrap="square" anchor="t" lIns="0" rIns="0" tIns="0" bIns="0">
+            <a:spAutoFit/>
+          </a:bodyPr>
+          <a:lstStyle/>
+          <a:p>
+            <a:pPr algn="l">
+              <a:lnSpc>
+                <a:spcPct val="140000"/>
+              </a:lnSpc>
+              <a:spcAft>
+                <a:spcPts val="1200"/>
+              </a:spcAft>
+            </a:pPr>
+            <a:r>
+              <a:rPr sz="1900" b="1" i="0">
+                <a:solidFill>
+                  <a:srgbClr val="191E19"/>
+                </a:solidFill>
+                <a:latin typeface="Georgia"/>
+              </a:rPr>
+              <a:t>Yes — and that is what the test period measures.</a:t>
+            </a:r>
+          </a:p>
+          <a:p>
+            <a:pPr algn="l">
+              <a:lnSpc>
+                <a:spcPct val="140000"/>
+              </a:lnSpc>
+              <a:spcAft>
+                <a:spcPts val="1200"/>
+              </a:spcAft>
+            </a:pPr>
+            <a:r>
+              <a:rPr sz="1350" b="0" i="0">
+                <a:solidFill>
+                  <a:srgbClr val="5C625A"/>
+                </a:solidFill>
+                <a:latin typeface="Segoe UI"/>
+              </a:rPr>
+              <a:t>Training stopped at 2025-04-15; all 9,776 test rows fall after it. The model was scored on dates it had never seen — a real out-of-sample forecast.</a:t>
+            </a:r>
+          </a:p>
+          <a:p>
+            <a:pPr algn="l">
+              <a:lnSpc>
+                <a:spcPct val="140000"/>
+              </a:lnSpc>
+              <a:spcAft>
+                <a:spcPts val="0"/>
+              </a:spcAft>
+            </a:pPr>
+            <a:r>
+              <a:rPr sz="1350" b="0" i="0">
+                <a:solidFill>
+                  <a:srgbClr val="5C625A"/>
+                </a:solidFill>
+                <a:latin typeface="Segoe UI"/>
+              </a:rPr>
+              <a:t>What it cannot do is forecast today from a series that went quiet in 2022 — and the app prints the real date rather than hiding it.</a:t>
+            </a:r>
+          </a:p>
+        </p:txBody>
+      </p:sp>
+      <p:sp>
+        <p:nvSpPr>
+          <p:cNvPr id="22" name="TextBox 21"/>
+          <p:cNvSpPr txBox="1"/>
+          <p:nvPr/>
+        </p:nvSpPr>
+        <p:spPr>
+          <a:xfrm>
+            <a:off x="822960" y="6199632"/>
+            <a:ext cx="9631375" cy="457200"/>
+          </a:xfrm>
+          <a:prstGeom prst="rect">
+            <a:avLst/>
+          </a:prstGeom>
+          <a:noFill/>
+        </p:spPr>
+        <p:txBody>
+          <a:bodyPr wrap="square" anchor="t" lIns="0" rIns="0" tIns="0" bIns="0">
+            <a:spAutoFit/>
+          </a:bodyPr>
+          <a:lstStyle/>
+          <a:p>
+            <a:pPr algn="l">
+              <a:lnSpc>
+                <a:spcPct val="135000"/>
+              </a:lnSpc>
+              <a:spcAft>
+                <a:spcPts val="0"/>
+              </a:spcAft>
+            </a:pPr>
+            <a:r>
+              <a:rPr sz="950" b="0" i="0" spc="60">
+                <a:solidFill>
+                  <a:srgbClr val="5C625A"/>
+                </a:solidFill>
+                <a:latin typeface="Consolas"/>
+              </a:rPr>
+              <a:t>Rice at Phnom Penh, wholesale: last recorded June 2022, so the app labels its forecast July 2022 — not next month.</a:t>
+            </a:r>
+          </a:p>
+        </p:txBody>
+      </p:sp>
     </p:spTree>
   </p:cSld>
   <p:clrMapOvr>
@@ -10580,7 +11194,7 @@
                 </a:solidFill>
                 <a:latin typeface="Consolas"/>
               </a:rPr>
-              <a:t>THE QUESTION</a:t>
+              <a:t>PROBLEM &amp; SOLUTION</a:t>
             </a:r>
           </a:p>
         </p:txBody>
@@ -10622,7 +11236,7 @@
                 </a:solidFill>
                 <a:latin typeface="Georgia"/>
               </a:rPr>
-              <a:t>A price is only useful</a:t>
+              <a:t>An early warning</a:t>
             </a:r>
           </a:p>
         </p:txBody>
@@ -10664,7 +11278,7 @@
                 </a:solidFill>
                 <a:latin typeface="Georgia"/>
               </a:rPr>
-              <a:t>before you pay it</a:t>
+              <a:t>only works if it arrives</a:t>
             </a:r>
           </a:p>
         </p:txBody>
@@ -10713,98 +11327,14 @@
       </p:sp>
       <p:sp>
         <p:nvSpPr>
-          <p:cNvPr id="7" name="TextBox 6"/>
-          <p:cNvSpPr txBox="1"/>
-          <p:nvPr/>
-        </p:nvSpPr>
-        <p:spPr>
-          <a:xfrm>
-            <a:off x="822960" y="2286000"/>
-            <a:ext cx="5669280" cy="1463040"/>
-          </a:xfrm>
-          <a:prstGeom prst="rect">
-            <a:avLst/>
-          </a:prstGeom>
-          <a:noFill/>
-        </p:spPr>
-        <p:txBody>
-          <a:bodyPr wrap="square" anchor="t" lIns="0" rIns="0" tIns="0" bIns="0">
-            <a:spAutoFit/>
-          </a:bodyPr>
-          <a:lstStyle/>
-          <a:p>
-            <a:pPr algn="l">
-              <a:lnSpc>
-                <a:spcPct val="150000"/>
-              </a:lnSpc>
-              <a:spcAft>
-                <a:spcPts val="0"/>
-              </a:spcAft>
-            </a:pPr>
-            <a:r>
-              <a:rPr sz="1700" b="0" i="0">
-                <a:solidFill>
-                  <a:srgbClr val="191E19"/>
-                </a:solidFill>
-                <a:latin typeface="Segoe UI"/>
-              </a:rPr>
-              <a:t>The World Food Programme publishes what food cost in Cambodian markets — twenty-three years of it, updated monthly. What it does not publish is what food will cost next month.</a:t>
-            </a:r>
-          </a:p>
-        </p:txBody>
-      </p:sp>
-      <p:sp>
-        <p:nvSpPr>
-          <p:cNvPr id="8" name="TextBox 7"/>
-          <p:cNvSpPr txBox="1"/>
-          <p:nvPr/>
-        </p:nvSpPr>
-        <p:spPr>
-          <a:xfrm>
-            <a:off x="822960" y="4114800"/>
-            <a:ext cx="5669280" cy="1371600"/>
-          </a:xfrm>
-          <a:prstGeom prst="rect">
-            <a:avLst/>
-          </a:prstGeom>
-          <a:noFill/>
-        </p:spPr>
-        <p:txBody>
-          <a:bodyPr wrap="square" anchor="t" lIns="0" rIns="0" tIns="0" bIns="0">
-            <a:spAutoFit/>
-          </a:bodyPr>
-          <a:lstStyle/>
-          <a:p>
-            <a:pPr algn="l">
-              <a:lnSpc>
-                <a:spcPct val="150000"/>
-              </a:lnSpc>
-              <a:spcAft>
-                <a:spcPts val="0"/>
-              </a:spcAft>
-            </a:pPr>
-            <a:r>
-              <a:rPr sz="1600" b="0" i="0">
-                <a:solidFill>
-                  <a:srgbClr val="5C625A"/>
-                </a:solidFill>
-                <a:latin typeface="Segoe UI"/>
-              </a:rPr>
-              <a:t>That gap is the project: a trader deciding when to buy, a household budgeting for rice, an NGO sizing a food-assistance programme. All of them need the next number, not the last one.</a:t>
-            </a:r>
-          </a:p>
-        </p:txBody>
-      </p:sp>
-      <p:sp>
-        <p:nvSpPr>
-          <p:cNvPr id="9" name="Rectangle 8"/>
+          <p:cNvPr id="7" name="Rectangle 6"/>
           <p:cNvSpPr/>
           <p:nvPr/>
         </p:nvSpPr>
         <p:spPr>
           <a:xfrm>
-            <a:off x="7040880" y="2194560"/>
-            <a:ext cx="4297680" cy="3108960"/>
+            <a:off x="822960" y="2194560"/>
+            <a:ext cx="5029200" cy="3611880"/>
           </a:xfrm>
           <a:prstGeom prst="rect">
             <a:avLst/>
@@ -10843,14 +11373,446 @@
       </p:sp>
       <p:sp>
         <p:nvSpPr>
-          <p:cNvPr id="10" name="Rectangle 9"/>
+          <p:cNvPr id="8" name="Rectangle 7"/>
           <p:cNvSpPr/>
           <p:nvPr/>
         </p:nvSpPr>
         <p:spPr>
           <a:xfrm>
-            <a:off x="7040880" y="2194560"/>
-            <a:ext cx="45720" cy="3108960"/>
+            <a:off x="822960" y="2194560"/>
+            <a:ext cx="45720" cy="3611880"/>
+          </a:xfrm>
+          <a:prstGeom prst="rect">
+            <a:avLst/>
+          </a:prstGeom>
+          <a:solidFill>
+            <a:srgbClr val="6B2545"/>
+          </a:solidFill>
+          <a:ln>
+            <a:noFill/>
+          </a:ln>
+          <a:effectLst/>
+        </p:spPr>
+        <p:style>
+          <a:lnRef idx="1">
+            <a:schemeClr val="accent1"/>
+          </a:lnRef>
+          <a:fillRef idx="3">
+            <a:schemeClr val="accent1"/>
+          </a:fillRef>
+          <a:effectRef idx="2">
+            <a:schemeClr val="accent1"/>
+          </a:effectRef>
+          <a:fontRef idx="minor">
+            <a:schemeClr val="lt1"/>
+          </a:fontRef>
+        </p:style>
+        <p:txBody>
+          <a:bodyPr rtlCol="0" anchor="ctr"/>
+          <a:lstStyle/>
+          <a:p>
+            <a:pPr algn="ctr"/>
+          </a:p>
+        </p:txBody>
+      </p:sp>
+      <p:sp>
+        <p:nvSpPr>
+          <p:cNvPr id="9" name="TextBox 8"/>
+          <p:cNvSpPr txBox="1"/>
+          <p:nvPr/>
+        </p:nvSpPr>
+        <p:spPr>
+          <a:xfrm>
+            <a:off x="1188720" y="2487168"/>
+            <a:ext cx="4297680" cy="274320"/>
+          </a:xfrm>
+          <a:prstGeom prst="rect">
+            <a:avLst/>
+          </a:prstGeom>
+          <a:noFill/>
+        </p:spPr>
+        <p:txBody>
+          <a:bodyPr wrap="square" anchor="t" lIns="0" rIns="0" tIns="0" bIns="0">
+            <a:spAutoFit/>
+          </a:bodyPr>
+          <a:lstStyle/>
+          <a:p>
+            <a:pPr algn="l">
+              <a:lnSpc>
+                <a:spcPct val="130000"/>
+              </a:lnSpc>
+              <a:spcAft>
+                <a:spcPts val="0"/>
+              </a:spcAft>
+            </a:pPr>
+            <a:r>
+              <a:rPr sz="1000" b="0" i="0" spc="200">
+                <a:solidFill>
+                  <a:srgbClr val="6B2545"/>
+                </a:solidFill>
+                <a:latin typeface="Consolas"/>
+              </a:rPr>
+              <a:t>PROBLEM</a:t>
+            </a:r>
+          </a:p>
+        </p:txBody>
+      </p:sp>
+      <p:sp>
+        <p:nvSpPr>
+          <p:cNvPr id="10" name="TextBox 9"/>
+          <p:cNvSpPr txBox="1"/>
+          <p:nvPr/>
+        </p:nvSpPr>
+        <p:spPr>
+          <a:xfrm>
+            <a:off x="1188720" y="2852928"/>
+            <a:ext cx="4297680" cy="731520"/>
+          </a:xfrm>
+          <a:prstGeom prst="rect">
+            <a:avLst/>
+          </a:prstGeom>
+          <a:noFill/>
+        </p:spPr>
+        <p:txBody>
+          <a:bodyPr wrap="square" anchor="t" lIns="0" rIns="0" tIns="0" bIns="0">
+            <a:spAutoFit/>
+          </a:bodyPr>
+          <a:lstStyle/>
+          <a:p>
+            <a:pPr algn="l">
+              <a:lnSpc>
+                <a:spcPct val="115000"/>
+              </a:lnSpc>
+              <a:spcAft>
+                <a:spcPts val="0"/>
+              </a:spcAft>
+            </a:pPr>
+            <a:r>
+              <a:rPr sz="1900" b="1" i="0">
+                <a:solidFill>
+                  <a:srgbClr val="191E19"/>
+                </a:solidFill>
+                <a:latin typeface="Georgia"/>
+              </a:rPr>
+              <a:t>A price rise lands hardest on the people with the least slack.</a:t>
+            </a:r>
+          </a:p>
+        </p:txBody>
+      </p:sp>
+      <p:sp>
+        <p:nvSpPr>
+          <p:cNvPr id="11" name="Rectangle 10"/>
+          <p:cNvSpPr/>
+          <p:nvPr/>
+        </p:nvSpPr>
+        <p:spPr>
+          <a:xfrm>
+            <a:off x="1188720" y="3675888"/>
+            <a:ext cx="128016" cy="128016"/>
+          </a:xfrm>
+          <a:prstGeom prst="rect">
+            <a:avLst/>
+          </a:prstGeom>
+          <a:solidFill>
+            <a:srgbClr val="6B2545"/>
+          </a:solidFill>
+          <a:ln>
+            <a:noFill/>
+          </a:ln>
+          <a:effectLst/>
+        </p:spPr>
+        <p:style>
+          <a:lnRef idx="1">
+            <a:schemeClr val="accent1"/>
+          </a:lnRef>
+          <a:fillRef idx="3">
+            <a:schemeClr val="accent1"/>
+          </a:fillRef>
+          <a:effectRef idx="2">
+            <a:schemeClr val="accent1"/>
+          </a:effectRef>
+          <a:fontRef idx="minor">
+            <a:schemeClr val="lt1"/>
+          </a:fontRef>
+        </p:style>
+        <p:txBody>
+          <a:bodyPr rtlCol="0" anchor="ctr"/>
+          <a:lstStyle/>
+          <a:p>
+            <a:pPr algn="ctr"/>
+          </a:p>
+        </p:txBody>
+      </p:sp>
+      <p:sp>
+        <p:nvSpPr>
+          <p:cNvPr id="12" name="TextBox 11"/>
+          <p:cNvSpPr txBox="1"/>
+          <p:nvPr/>
+        </p:nvSpPr>
+        <p:spPr>
+          <a:xfrm>
+            <a:off x="1481328" y="3611880"/>
+            <a:ext cx="4005072" cy="548640"/>
+          </a:xfrm>
+          <a:prstGeom prst="rect">
+            <a:avLst/>
+          </a:prstGeom>
+          <a:noFill/>
+        </p:spPr>
+        <p:txBody>
+          <a:bodyPr wrap="square" anchor="t" lIns="0" rIns="0" tIns="0" bIns="0">
+            <a:spAutoFit/>
+          </a:bodyPr>
+          <a:lstStyle/>
+          <a:p>
+            <a:pPr algn="l">
+              <a:lnSpc>
+                <a:spcPct val="140000"/>
+              </a:lnSpc>
+              <a:spcAft>
+                <a:spcPts val="0"/>
+              </a:spcAft>
+            </a:pPr>
+            <a:r>
+              <a:rPr sz="1350" b="0" i="0">
+                <a:solidFill>
+                  <a:srgbClr val="5C625A"/>
+                </a:solidFill>
+                <a:latin typeface="Segoe UI"/>
+              </a:rPr>
+              <a:t>For a low-income household food is the largest monthly cost, so a price rise is not an inconvenience.</a:t>
+            </a:r>
+          </a:p>
+        </p:txBody>
+      </p:sp>
+      <p:sp>
+        <p:nvSpPr>
+          <p:cNvPr id="13" name="Rectangle 12"/>
+          <p:cNvSpPr/>
+          <p:nvPr/>
+        </p:nvSpPr>
+        <p:spPr>
+          <a:xfrm>
+            <a:off x="1188720" y="4389120"/>
+            <a:ext cx="128016" cy="128016"/>
+          </a:xfrm>
+          <a:prstGeom prst="rect">
+            <a:avLst/>
+          </a:prstGeom>
+          <a:solidFill>
+            <a:srgbClr val="6B2545"/>
+          </a:solidFill>
+          <a:ln>
+            <a:noFill/>
+          </a:ln>
+          <a:effectLst/>
+        </p:spPr>
+        <p:style>
+          <a:lnRef idx="1">
+            <a:schemeClr val="accent1"/>
+          </a:lnRef>
+          <a:fillRef idx="3">
+            <a:schemeClr val="accent1"/>
+          </a:fillRef>
+          <a:effectRef idx="2">
+            <a:schemeClr val="accent1"/>
+          </a:effectRef>
+          <a:fontRef idx="minor">
+            <a:schemeClr val="lt1"/>
+          </a:fontRef>
+        </p:style>
+        <p:txBody>
+          <a:bodyPr rtlCol="0" anchor="ctr"/>
+          <a:lstStyle/>
+          <a:p>
+            <a:pPr algn="ctr"/>
+          </a:p>
+        </p:txBody>
+      </p:sp>
+      <p:sp>
+        <p:nvSpPr>
+          <p:cNvPr id="14" name="TextBox 13"/>
+          <p:cNvSpPr txBox="1"/>
+          <p:nvPr/>
+        </p:nvSpPr>
+        <p:spPr>
+          <a:xfrm>
+            <a:off x="1481328" y="4325112"/>
+            <a:ext cx="4005072" cy="548640"/>
+          </a:xfrm>
+          <a:prstGeom prst="rect">
+            <a:avLst/>
+          </a:prstGeom>
+          <a:noFill/>
+        </p:spPr>
+        <p:txBody>
+          <a:bodyPr wrap="square" anchor="t" lIns="0" rIns="0" tIns="0" bIns="0">
+            <a:spAutoFit/>
+          </a:bodyPr>
+          <a:lstStyle/>
+          <a:p>
+            <a:pPr algn="l">
+              <a:lnSpc>
+                <a:spcPct val="140000"/>
+              </a:lnSpc>
+              <a:spcAft>
+                <a:spcPts val="0"/>
+              </a:spcAft>
+            </a:pPr>
+            <a:r>
+              <a:rPr sz="1350" b="0" i="0">
+                <a:solidFill>
+                  <a:srgbClr val="5C625A"/>
+                </a:solidFill>
+                <a:latin typeface="Segoe UI"/>
+              </a:rPr>
+              <a:t>WFP tracks these markets to catch that early, but publishes what prices were — not what they will be.</a:t>
+            </a:r>
+          </a:p>
+        </p:txBody>
+      </p:sp>
+      <p:sp>
+        <p:nvSpPr>
+          <p:cNvPr id="15" name="Rectangle 14"/>
+          <p:cNvSpPr/>
+          <p:nvPr/>
+        </p:nvSpPr>
+        <p:spPr>
+          <a:xfrm>
+            <a:off x="1188720" y="5102352"/>
+            <a:ext cx="128016" cy="128016"/>
+          </a:xfrm>
+          <a:prstGeom prst="rect">
+            <a:avLst/>
+          </a:prstGeom>
+          <a:solidFill>
+            <a:srgbClr val="6B2545"/>
+          </a:solidFill>
+          <a:ln>
+            <a:noFill/>
+          </a:ln>
+          <a:effectLst/>
+        </p:spPr>
+        <p:style>
+          <a:lnRef idx="1">
+            <a:schemeClr val="accent1"/>
+          </a:lnRef>
+          <a:fillRef idx="3">
+            <a:schemeClr val="accent1"/>
+          </a:fillRef>
+          <a:effectRef idx="2">
+            <a:schemeClr val="accent1"/>
+          </a:effectRef>
+          <a:fontRef idx="minor">
+            <a:schemeClr val="lt1"/>
+          </a:fontRef>
+        </p:style>
+        <p:txBody>
+          <a:bodyPr rtlCol="0" anchor="ctr"/>
+          <a:lstStyle/>
+          <a:p>
+            <a:pPr algn="ctr"/>
+          </a:p>
+        </p:txBody>
+      </p:sp>
+      <p:sp>
+        <p:nvSpPr>
+          <p:cNvPr id="16" name="TextBox 15"/>
+          <p:cNvSpPr txBox="1"/>
+          <p:nvPr/>
+        </p:nvSpPr>
+        <p:spPr>
+          <a:xfrm>
+            <a:off x="1481328" y="5038344"/>
+            <a:ext cx="4005072" cy="548640"/>
+          </a:xfrm>
+          <a:prstGeom prst="rect">
+            <a:avLst/>
+          </a:prstGeom>
+          <a:noFill/>
+        </p:spPr>
+        <p:txBody>
+          <a:bodyPr wrap="square" anchor="t" lIns="0" rIns="0" tIns="0" bIns="0">
+            <a:spAutoFit/>
+          </a:bodyPr>
+          <a:lstStyle/>
+          <a:p>
+            <a:pPr algn="l">
+              <a:lnSpc>
+                <a:spcPct val="140000"/>
+              </a:lnSpc>
+              <a:spcAft>
+                <a:spcPts val="0"/>
+              </a:spcAft>
+            </a:pPr>
+            <a:r>
+              <a:rPr sz="1350" b="0" i="0">
+                <a:solidFill>
+                  <a:srgbClr val="5C625A"/>
+                </a:solidFill>
+                <a:latin typeface="Segoe UI"/>
+              </a:rPr>
+              <a:t>And the record itself ships as a 85,107-row CSV: readable by analysts, nobody else.</a:t>
+            </a:r>
+          </a:p>
+        </p:txBody>
+      </p:sp>
+      <p:sp>
+        <p:nvSpPr>
+          <p:cNvPr id="17" name="Rectangle 16"/>
+          <p:cNvSpPr/>
+          <p:nvPr/>
+        </p:nvSpPr>
+        <p:spPr>
+          <a:xfrm>
+            <a:off x="6336792" y="2194560"/>
+            <a:ext cx="5029200" cy="3611880"/>
+          </a:xfrm>
+          <a:prstGeom prst="rect">
+            <a:avLst/>
+          </a:prstGeom>
+          <a:solidFill>
+            <a:srgbClr val="FCFBF7"/>
+          </a:solidFill>
+          <a:ln w="12700">
+            <a:solidFill>
+              <a:srgbClr val="DCD9C9"/>
+            </a:solidFill>
+          </a:ln>
+          <a:effectLst/>
+        </p:spPr>
+        <p:style>
+          <a:lnRef idx="1">
+            <a:schemeClr val="accent1"/>
+          </a:lnRef>
+          <a:fillRef idx="3">
+            <a:schemeClr val="accent1"/>
+          </a:fillRef>
+          <a:effectRef idx="2">
+            <a:schemeClr val="accent1"/>
+          </a:effectRef>
+          <a:fontRef idx="minor">
+            <a:schemeClr val="lt1"/>
+          </a:fontRef>
+        </p:style>
+        <p:txBody>
+          <a:bodyPr rtlCol="0" anchor="ctr"/>
+          <a:lstStyle/>
+          <a:p>
+            <a:pPr algn="ctr"/>
+          </a:p>
+        </p:txBody>
+      </p:sp>
+      <p:sp>
+        <p:nvSpPr>
+          <p:cNvPr id="18" name="Rectangle 17"/>
+          <p:cNvSpPr/>
+          <p:nvPr/>
+        </p:nvSpPr>
+        <p:spPr>
+          <a:xfrm>
+            <a:off x="6336792" y="2194560"/>
+            <a:ext cx="45720" cy="3611880"/>
           </a:xfrm>
           <a:prstGeom prst="rect">
             <a:avLst/>
@@ -10887,14 +11849,14 @@
       </p:sp>
       <p:sp>
         <p:nvSpPr>
-          <p:cNvPr id="11" name="TextBox 10"/>
-          <p:cNvSpPr txBox="1"/>
-          <p:nvPr/>
-        </p:nvSpPr>
-        <p:spPr>
-          <a:xfrm>
-            <a:off x="7406640" y="2560320"/>
-            <a:ext cx="3657600" cy="274320"/>
+          <p:cNvPr id="19" name="TextBox 18"/>
+          <p:cNvSpPr txBox="1"/>
+          <p:nvPr/>
+        </p:nvSpPr>
+        <p:spPr>
+          <a:xfrm>
+            <a:off x="6702552" y="2487168"/>
+            <a:ext cx="4297680" cy="274320"/>
           </a:xfrm>
           <a:prstGeom prst="rect">
             <a:avLst/>
@@ -10918,79 +11880,360 @@
             <a:r>
               <a:rPr sz="1000" b="0" i="0" spc="200">
                 <a:solidFill>
+                  <a:srgbClr val="2F5D46"/>
+                </a:solidFill>
+                <a:latin typeface="Consolas"/>
+              </a:rPr>
+              <a:t>SOLUTION</a:t>
+            </a:r>
+          </a:p>
+        </p:txBody>
+      </p:sp>
+      <p:sp>
+        <p:nvSpPr>
+          <p:cNvPr id="20" name="TextBox 19"/>
+          <p:cNvSpPr txBox="1"/>
+          <p:nvPr/>
+        </p:nvSpPr>
+        <p:spPr>
+          <a:xfrm>
+            <a:off x="6702552" y="2852928"/>
+            <a:ext cx="4297680" cy="731520"/>
+          </a:xfrm>
+          <a:prstGeom prst="rect">
+            <a:avLst/>
+          </a:prstGeom>
+          <a:noFill/>
+        </p:spPr>
+        <p:txBody>
+          <a:bodyPr wrap="square" anchor="t" lIns="0" rIns="0" tIns="0" bIns="0">
+            <a:spAutoFit/>
+          </a:bodyPr>
+          <a:lstStyle/>
+          <a:p>
+            <a:pPr algn="l">
+              <a:lnSpc>
+                <a:spcPct val="115000"/>
+              </a:lnSpc>
+              <a:spcAft>
+                <a:spcPts val="0"/>
+              </a:spcAft>
+            </a:pPr>
+            <a:r>
+              <a:rPr sz="1900" b="1" i="0">
+                <a:solidFill>
+                  <a:srgbClr val="191E19"/>
+                </a:solidFill>
+                <a:latin typeface="Georgia"/>
+              </a:rPr>
+              <a:t>Make the answer reachable in two clicks or one message.</a:t>
+            </a:r>
+          </a:p>
+        </p:txBody>
+      </p:sp>
+      <p:sp>
+        <p:nvSpPr>
+          <p:cNvPr id="21" name="Rectangle 20"/>
+          <p:cNvSpPr/>
+          <p:nvPr/>
+        </p:nvSpPr>
+        <p:spPr>
+          <a:xfrm>
+            <a:off x="6702552" y="3675888"/>
+            <a:ext cx="128016" cy="128016"/>
+          </a:xfrm>
+          <a:prstGeom prst="rect">
+            <a:avLst/>
+          </a:prstGeom>
+          <a:solidFill>
+            <a:srgbClr val="2F5D46"/>
+          </a:solidFill>
+          <a:ln>
+            <a:noFill/>
+          </a:ln>
+          <a:effectLst/>
+        </p:spPr>
+        <p:style>
+          <a:lnRef idx="1">
+            <a:schemeClr val="accent1"/>
+          </a:lnRef>
+          <a:fillRef idx="3">
+            <a:schemeClr val="accent1"/>
+          </a:fillRef>
+          <a:effectRef idx="2">
+            <a:schemeClr val="accent1"/>
+          </a:effectRef>
+          <a:fontRef idx="minor">
+            <a:schemeClr val="lt1"/>
+          </a:fontRef>
+        </p:style>
+        <p:txBody>
+          <a:bodyPr rtlCol="0" anchor="ctr"/>
+          <a:lstStyle/>
+          <a:p>
+            <a:pPr algn="ctr"/>
+          </a:p>
+        </p:txBody>
+      </p:sp>
+      <p:sp>
+        <p:nvSpPr>
+          <p:cNvPr id="22" name="TextBox 21"/>
+          <p:cNvSpPr txBox="1"/>
+          <p:nvPr/>
+        </p:nvSpPr>
+        <p:spPr>
+          <a:xfrm>
+            <a:off x="6995160" y="3611880"/>
+            <a:ext cx="4005072" cy="548640"/>
+          </a:xfrm>
+          <a:prstGeom prst="rect">
+            <a:avLst/>
+          </a:prstGeom>
+          <a:noFill/>
+        </p:spPr>
+        <p:txBody>
+          <a:bodyPr wrap="square" anchor="t" lIns="0" rIns="0" tIns="0" bIns="0">
+            <a:spAutoFit/>
+          </a:bodyPr>
+          <a:lstStyle/>
+          <a:p>
+            <a:pPr algn="l">
+              <a:lnSpc>
+                <a:spcPct val="140000"/>
+              </a:lnSpc>
+              <a:spcAft>
+                <a:spcPts val="0"/>
+              </a:spcAft>
+            </a:pPr>
+            <a:r>
+              <a:rPr sz="1350" b="0" i="0">
+                <a:solidFill>
                   <a:srgbClr val="5C625A"/>
                 </a:solidFill>
+                <a:latin typeface="Segoe UI"/>
+              </a:rPr>
+              <a:t>3,442 price series across 46 commodities and 76 markets, charted for anyone with a browser.</a:t>
+            </a:r>
+          </a:p>
+        </p:txBody>
+      </p:sp>
+      <p:sp>
+        <p:nvSpPr>
+          <p:cNvPr id="23" name="Rectangle 22"/>
+          <p:cNvSpPr/>
+          <p:nvPr/>
+        </p:nvSpPr>
+        <p:spPr>
+          <a:xfrm>
+            <a:off x="6702552" y="4389120"/>
+            <a:ext cx="128016" cy="128016"/>
+          </a:xfrm>
+          <a:prstGeom prst="rect">
+            <a:avLst/>
+          </a:prstGeom>
+          <a:solidFill>
+            <a:srgbClr val="2F5D46"/>
+          </a:solidFill>
+          <a:ln>
+            <a:noFill/>
+          </a:ln>
+          <a:effectLst/>
+        </p:spPr>
+        <p:style>
+          <a:lnRef idx="1">
+            <a:schemeClr val="accent1"/>
+          </a:lnRef>
+          <a:fillRef idx="3">
+            <a:schemeClr val="accent1"/>
+          </a:fillRef>
+          <a:effectRef idx="2">
+            <a:schemeClr val="accent1"/>
+          </a:effectRef>
+          <a:fontRef idx="minor">
+            <a:schemeClr val="lt1"/>
+          </a:fontRef>
+        </p:style>
+        <p:txBody>
+          <a:bodyPr rtlCol="0" anchor="ctr"/>
+          <a:lstStyle/>
+          <a:p>
+            <a:pPr algn="ctr"/>
+          </a:p>
+        </p:txBody>
+      </p:sp>
+      <p:sp>
+        <p:nvSpPr>
+          <p:cNvPr id="24" name="TextBox 23"/>
+          <p:cNvSpPr txBox="1"/>
+          <p:nvPr/>
+        </p:nvSpPr>
+        <p:spPr>
+          <a:xfrm>
+            <a:off x="6995160" y="4325112"/>
+            <a:ext cx="4005072" cy="548640"/>
+          </a:xfrm>
+          <a:prstGeom prst="rect">
+            <a:avLst/>
+          </a:prstGeom>
+          <a:noFill/>
+        </p:spPr>
+        <p:txBody>
+          <a:bodyPr wrap="square" anchor="t" lIns="0" rIns="0" tIns="0" bIns="0">
+            <a:spAutoFit/>
+          </a:bodyPr>
+          <a:lstStyle/>
+          <a:p>
+            <a:pPr algn="l">
+              <a:lnSpc>
+                <a:spcPct val="140000"/>
+              </a:lnSpc>
+              <a:spcAft>
+                <a:spcPts val="0"/>
+              </a:spcAft>
+            </a:pPr>
+            <a:r>
+              <a:rPr sz="1350" b="0" i="0">
+                <a:solidFill>
+                  <a:srgbClr val="5C625A"/>
+                </a:solidFill>
+                <a:latin typeface="Segoe UI"/>
+              </a:rPr>
+              <a:t>A next-period forecast on each, with the line between recorded and predicted drawn honestly.</a:t>
+            </a:r>
+          </a:p>
+        </p:txBody>
+      </p:sp>
+      <p:sp>
+        <p:nvSpPr>
+          <p:cNvPr id="25" name="Rectangle 24"/>
+          <p:cNvSpPr/>
+          <p:nvPr/>
+        </p:nvSpPr>
+        <p:spPr>
+          <a:xfrm>
+            <a:off x="6702552" y="5102352"/>
+            <a:ext cx="128016" cy="128016"/>
+          </a:xfrm>
+          <a:prstGeom prst="rect">
+            <a:avLst/>
+          </a:prstGeom>
+          <a:solidFill>
+            <a:srgbClr val="2F5D46"/>
+          </a:solidFill>
+          <a:ln>
+            <a:noFill/>
+          </a:ln>
+          <a:effectLst/>
+        </p:spPr>
+        <p:style>
+          <a:lnRef idx="1">
+            <a:schemeClr val="accent1"/>
+          </a:lnRef>
+          <a:fillRef idx="3">
+            <a:schemeClr val="accent1"/>
+          </a:fillRef>
+          <a:effectRef idx="2">
+            <a:schemeClr val="accent1"/>
+          </a:effectRef>
+          <a:fontRef idx="minor">
+            <a:schemeClr val="lt1"/>
+          </a:fontRef>
+        </p:style>
+        <p:txBody>
+          <a:bodyPr rtlCol="0" anchor="ctr"/>
+          <a:lstStyle/>
+          <a:p>
+            <a:pPr algn="ctr"/>
+          </a:p>
+        </p:txBody>
+      </p:sp>
+      <p:sp>
+        <p:nvSpPr>
+          <p:cNvPr id="26" name="TextBox 25"/>
+          <p:cNvSpPr txBox="1"/>
+          <p:nvPr/>
+        </p:nvSpPr>
+        <p:spPr>
+          <a:xfrm>
+            <a:off x="6995160" y="5038344"/>
+            <a:ext cx="4005072" cy="548640"/>
+          </a:xfrm>
+          <a:prstGeom prst="rect">
+            <a:avLst/>
+          </a:prstGeom>
+          <a:noFill/>
+        </p:spPr>
+        <p:txBody>
+          <a:bodyPr wrap="square" anchor="t" lIns="0" rIns="0" tIns="0" bIns="0">
+            <a:spAutoFit/>
+          </a:bodyPr>
+          <a:lstStyle/>
+          <a:p>
+            <a:pPr algn="l">
+              <a:lnSpc>
+                <a:spcPct val="140000"/>
+              </a:lnSpc>
+              <a:spcAft>
+                <a:spcPts val="0"/>
+              </a:spcAft>
+            </a:pPr>
+            <a:r>
+              <a:rPr sz="1350" b="0" i="0">
+                <a:solidFill>
+                  <a:srgbClr val="5C625A"/>
+                </a:solidFill>
+                <a:latin typeface="Segoe UI"/>
+              </a:rPr>
+              <a:t>Free to run — so a ministry, an NGO or a co-op could stand the same thing up on its own feed.</a:t>
+            </a:r>
+          </a:p>
+        </p:txBody>
+      </p:sp>
+      <p:sp>
+        <p:nvSpPr>
+          <p:cNvPr id="27" name="TextBox 26"/>
+          <p:cNvSpPr txBox="1"/>
+          <p:nvPr/>
+        </p:nvSpPr>
+        <p:spPr>
+          <a:xfrm>
+            <a:off x="5779008" y="3703320"/>
+            <a:ext cx="548640" cy="365760"/>
+          </a:xfrm>
+          <a:prstGeom prst="rect">
+            <a:avLst/>
+          </a:prstGeom>
+          <a:noFill/>
+        </p:spPr>
+        <p:txBody>
+          <a:bodyPr wrap="square" anchor="t" lIns="0" rIns="0" tIns="0" bIns="0">
+            <a:spAutoFit/>
+          </a:bodyPr>
+          <a:lstStyle/>
+          <a:p>
+            <a:pPr algn="ctr">
+              <a:lnSpc>
+                <a:spcPct val="130000"/>
+              </a:lnSpc>
+              <a:spcAft>
+                <a:spcPts val="0"/>
+              </a:spcAft>
+            </a:pPr>
+            <a:r>
+              <a:rPr sz="2200" b="0" i="0">
+                <a:solidFill>
+                  <a:srgbClr val="2F5D46"/>
+                </a:solidFill>
                 <a:latin typeface="Consolas"/>
               </a:rPr>
-              <a:t>SCOPE</a:t>
-            </a:r>
-          </a:p>
-        </p:txBody>
-      </p:sp>
-      <p:sp>
-        <p:nvSpPr>
-          <p:cNvPr id="12" name="TextBox 11"/>
-          <p:cNvSpPr txBox="1"/>
-          <p:nvPr/>
-        </p:nvSpPr>
-        <p:spPr>
-          <a:xfrm>
-            <a:off x="7406640" y="3017520"/>
-            <a:ext cx="3566160" cy="1828800"/>
-          </a:xfrm>
-          <a:prstGeom prst="rect">
-            <a:avLst/>
-          </a:prstGeom>
-          <a:noFill/>
-        </p:spPr>
-        <p:txBody>
-          <a:bodyPr wrap="square" anchor="t" lIns="0" rIns="0" tIns="0" bIns="0">
-            <a:spAutoFit/>
-          </a:bodyPr>
-          <a:lstStyle/>
-          <a:p>
-            <a:pPr algn="l">
-              <a:lnSpc>
-                <a:spcPct val="140000"/>
-              </a:lnSpc>
-              <a:spcAft>
-                <a:spcPts val="1000"/>
-              </a:spcAft>
-            </a:pPr>
-            <a:r>
-              <a:rPr sz="2000" b="1" i="0">
-                <a:solidFill>
-                  <a:srgbClr val="191E19"/>
-                </a:solidFill>
-                <a:latin typeface="Georgia"/>
-              </a:rPr>
-              <a:t>Predict the next reported price</a:t>
-            </a:r>
-          </a:p>
-          <a:p>
-            <a:pPr algn="l">
-              <a:lnSpc>
-                <a:spcPct val="140000"/>
-              </a:lnSpc>
-              <a:spcAft>
-                <a:spcPts val="0"/>
-              </a:spcAft>
-            </a:pPr>
-            <a:r>
-              <a:rPr sz="1500" b="0" i="0">
-                <a:solidFill>
-                  <a:srgbClr val="5C625A"/>
-                </a:solidFill>
-                <a:latin typeface="Segoe UI"/>
-              </a:rPr>
-              <a:t>for a given commodity at a given market — and make that answer reachable in two clicks or one chat message.</a:t>
-            </a:r>
-          </a:p>
-        </p:txBody>
-      </p:sp>
-      <p:sp>
-        <p:nvSpPr>
-          <p:cNvPr id="13" name="TextBox 12"/>
+              <a:t>→</a:t>
+            </a:r>
+          </a:p>
+        </p:txBody>
+      </p:sp>
+      <p:sp>
+        <p:nvSpPr>
+          <p:cNvPr id="28" name="TextBox 27"/>
           <p:cNvSpPr txBox="1"/>
           <p:nvPr/>
         </p:nvSpPr>
@@ -11025,7 +12268,7 @@
                 </a:solidFill>
                 <a:latin typeface="Consolas"/>
               </a:rPr>
-              <a:t>Not a trading signal. A next-period estimate with its uncertainty made visible.</a:t>
+              <a:t>A demonstration on a snapshot, not a deployed service — the data ends March 2026 and the app says so, series by series.</a:t>
             </a:r>
           </a:p>
         </p:txBody>

</xml_diff>